<commit_message>
docs: update August 10 presentation
</commit_message>
<xml_diff>
--- a/PPT/胡丹-0810.pptx
+++ b/PPT/胡丹-0810.pptx
@@ -532,15 +532,7 @@
           <a:bodyPr/>
           <a:lstStyle/>
           <a:p>
-            <a:r>
-              <a:t>汇报口径：本次分为“论文方法复现”和“Embedding/SID 优化探索”两部分。所有最终生成式指标都来自固定 10,000 条 Validation，而不是完整 Validation 或 Test，因此当前结论用于方法选择，不能作为最终上线或论文 Test 结论。</a:t>
-            </a:r>
-          </a:p>
-          <a:p/>
-          <a:p>
-            <a:r>
-              <a:t>这里的生成式检索不是直接生成 POI 名称，而是让语言模型生成可映射到 POI 的离散标识符，再通过冻结映射还原实体。后续分析重点区分三件事：标识符结构是否合理、模型是否能预测、解码后是否真正召回目标。</a:t>
-            </a:r>
+            <a:endParaRPr kumimoji="1" lang="zh-CN" altLang="en-US" dirty="0"/>
           </a:p>
         </p:txBody>
       </p:sp>
@@ -573,580 +565,6 @@
         <p14:creationId xmlns:p14="http://schemas.microsoft.com/office/powerpoint/2010/main" val="2009092158"/>
       </p:ext>
     </p:extLst>
-  </p:cSld>
-  <p:clrMapOvr>
-    <a:masterClrMapping/>
-  </p:clrMapOvr>
-</p:notes>
-</file>
-
-<file path=ppt/notesSlides/notesSlide10.xml><?xml version="1.0" encoding="utf-8"?>
-<p:notes xmlns:a="http://schemas.openxmlformats.org/drawingml/2006/main" xmlns:p="http://schemas.openxmlformats.org/presentationml/2006/main" xmlns:r="http://schemas.openxmlformats.org/officeDocument/2006/relationships">
-  <p:cSld>
-    <p:spTree>
-      <p:nvGrpSpPr>
-        <p:cNvPr id="1" name=""/>
-        <p:cNvGrpSpPr/>
-        <p:nvPr/>
-      </p:nvGrpSpPr>
-      <p:grpSpPr>
-        <a:xfrm>
-          <a:off x="0" y="0"/>
-          <a:ext cx="0" cy="0"/>
-          <a:chOff x="0" y="0"/>
-          <a:chExt cx="0" cy="0"/>
-        </a:xfrm>
-      </p:grpSpPr>
-      <p:sp>
-        <p:nvSpPr>
-          <p:cNvPr id="2" name="Slide Image Placeholder 1"/>
-          <p:cNvSpPr>
-            <a:spLocks noGrp="1"/>
-          </p:cNvSpPr>
-          <p:nvPr>
-            <p:ph type="sldImg" idx="2"/>
-          </p:nvPr>
-        </p:nvSpPr>
-        <p:spPr/>
-      </p:sp>
-      <p:sp>
-        <p:nvSpPr>
-          <p:cNvPr id="3" name="Notes Placeholder 2"/>
-          <p:cNvSpPr>
-            <a:spLocks noGrp="1"/>
-          </p:cNvSpPr>
-          <p:nvPr>
-            <p:ph type="body" idx="3" sz="quarter"/>
-          </p:nvPr>
-        </p:nvSpPr>
-        <p:spPr/>
-        <p:txBody>
-          <a:bodyPr/>
-          <a:lstStyle/>
-          <a:p>
-            <a:r>
-              <a:t>Teacher-Forcing 的作用是定位哪一层难学：模型一次前向，后一位置始终看到真实前缀，因此不包含 Beam Search、非法 ID 和前层错误传播。Top-10 表示真实 Token 是否进入该位置的完整词表 Top-10；“所有位置 Top-10”也不等价于 Beam=10 的序列召回。</a:t>
-            </a:r>
-          </a:p>
-          <a:p/>
-          <a:p>
-            <a:r>
-              <a:t>GenPOI 的三层 SID 指标是在正确 GID1–GID6 已作为 gold prefix 的条件下得到的，不能直接解释成“不带地理前缀时，GenPOI SID 绝对优于 TIGER”。它说明的是：地理范围确定后，Centered Semantic SID 很容易区分；完整路径的损失主要发生在细粒度 GID4–GID6。</a:t>
-            </a:r>
-          </a:p>
-          <a:p/>
-          <a:p>
-            <a:r>
-              <a:t>GNPR 的 S1 Top-1 很低，而 S2/S3 在正确前缀下迅速恢复，说明问题更像根层组织与 Query 不对齐，而不是三层模型容量不足。自由生成时根层一旦选错，后层即使条件准确也无法回到目标分支。</a:t>
-            </a:r>
-          </a:p>
-        </p:txBody>
-      </p:sp>
-      <p:sp>
-        <p:nvSpPr>
-          <p:cNvPr id="4" name="Slide Number Placeholder 3"/>
-          <p:cNvSpPr>
-            <a:spLocks noGrp="1"/>
-          </p:cNvSpPr>
-          <p:nvPr>
-            <p:ph type="sldNum" idx="5" sz="quarter"/>
-          </p:nvPr>
-        </p:nvSpPr>
-        <p:spPr/>
-      </p:sp>
-    </p:spTree>
-  </p:cSld>
-  <p:clrMapOvr>
-    <a:masterClrMapping/>
-  </p:clrMapOvr>
-</p:notes>
-</file>
-
-<file path=ppt/notesSlides/notesSlide11.xml><?xml version="1.0" encoding="utf-8"?>
-<p:notes xmlns:a="http://schemas.openxmlformats.org/drawingml/2006/main" xmlns:p="http://schemas.openxmlformats.org/presentationml/2006/main" xmlns:r="http://schemas.openxmlformats.org/officeDocument/2006/relationships">
-  <p:cSld>
-    <p:spTree>
-      <p:nvGrpSpPr>
-        <p:cNvPr id="1" name=""/>
-        <p:cNvGrpSpPr/>
-        <p:nvPr/>
-      </p:nvGrpSpPr>
-      <p:grpSpPr>
-        <a:xfrm>
-          <a:off x="0" y="0"/>
-          <a:ext cx="0" cy="0"/>
-          <a:chOff x="0" y="0"/>
-          <a:chExt cx="0" cy="0"/>
-        </a:xfrm>
-      </p:grpSpPr>
-      <p:sp>
-        <p:nvSpPr>
-          <p:cNvPr id="2" name="Slide Image Placeholder 1"/>
-          <p:cNvSpPr>
-            <a:spLocks noGrp="1"/>
-          </p:cNvSpPr>
-          <p:nvPr>
-            <p:ph type="sldImg" idx="2"/>
-          </p:nvPr>
-        </p:nvSpPr>
-        <p:spPr/>
-      </p:sp>
-      <p:sp>
-        <p:nvSpPr>
-          <p:cNvPr id="3" name="Notes Placeholder 2"/>
-          <p:cNvSpPr>
-            <a:spLocks noGrp="1"/>
-          </p:cNvSpPr>
-          <p:nvPr>
-            <p:ph type="body" idx="3" sz="quarter"/>
-          </p:nvPr>
-        </p:nvSpPr>
-        <p:spPr/>
-        <p:txBody>
-          <a:bodyPr/>
-          <a:lstStyle/>
-          <a:p>
-            <a:r>
-              <a:t>E1 先对同一 POI 的 Train Query 做等权聚合，再与冻结内容向量按统一 α 融合。E2 的权重为 log1p(count)×IDF/DF，用发单频次增强可信 Query，同时抑制跨大量 POI 出现的泛词。E3 用 Kish 有效 Query 数给每个 POI 分配不同 α；其下降是研究假设不成立，不是实现报错，因为单一全库索引中每个 POI同时是别人的负候选，候选级变换破坏了全库相对几何。</a:t>
-            </a:r>
-          </a:p>
-          <a:p/>
-          <a:p>
-            <a:r>
-              <a:t>E4 只对有足够 Train 支持的类别估计公共 Query 中心，再从 POI Query 聚合中减去 β 倍类别方向；类别支持不足时中心置零。全库仍使用统一 α，避免重现 E3 的候选间尺度不一致。</a:t>
-            </a:r>
-          </a:p>
-          <a:p/>
-          <a:p>
-            <a:r>
-              <a:t>所有 Query 统计只使用 Train 正样本，BGE-M3 权重不更新，Validation 只比较预先列出的离散候选。该阶段优化的是离线 POI 向量，不使用目标 Validation POI 反向生成特征。</a:t>
-            </a:r>
-          </a:p>
-        </p:txBody>
-      </p:sp>
-      <p:sp>
-        <p:nvSpPr>
-          <p:cNvPr id="4" name="Slide Number Placeholder 3"/>
-          <p:cNvSpPr>
-            <a:spLocks noGrp="1"/>
-          </p:cNvSpPr>
-          <p:nvPr>
-            <p:ph type="sldNum" idx="5" sz="quarter"/>
-          </p:nvPr>
-        </p:nvSpPr>
-        <p:spPr/>
-      </p:sp>
-    </p:spTree>
-  </p:cSld>
-  <p:clrMapOvr>
-    <a:masterClrMapping/>
-  </p:clrMapOvr>
-</p:notes>
-</file>
-
-<file path=ppt/notesSlides/notesSlide12.xml><?xml version="1.0" encoding="utf-8"?>
-<p:notes xmlns:a="http://schemas.openxmlformats.org/drawingml/2006/main" xmlns:p="http://schemas.openxmlformats.org/presentationml/2006/main" xmlns:r="http://schemas.openxmlformats.org/officeDocument/2006/relationships">
-  <p:cSld>
-    <p:spTree>
-      <p:nvGrpSpPr>
-        <p:cNvPr id="1" name=""/>
-        <p:cNvGrpSpPr/>
-        <p:nvPr/>
-      </p:nvGrpSpPr>
-      <p:grpSpPr>
-        <a:xfrm>
-          <a:off x="0" y="0"/>
-          <a:ext cx="0" cy="0"/>
-          <a:chOff x="0" y="0"/>
-          <a:chExt cx="0" cy="0"/>
-        </a:xfrm>
-      </p:grpSpPr>
-      <p:sp>
-        <p:nvSpPr>
-          <p:cNvPr id="2" name="Slide Image Placeholder 1"/>
-          <p:cNvSpPr>
-            <a:spLocks noGrp="1"/>
-          </p:cNvSpPr>
-          <p:nvPr>
-            <p:ph type="sldImg" idx="2"/>
-          </p:nvPr>
-        </p:nvSpPr>
-        <p:spPr/>
-      </p:sp>
-      <p:sp>
-        <p:nvSpPr>
-          <p:cNvPr id="3" name="Notes Placeholder 2"/>
-          <p:cNvSpPr>
-            <a:spLocks noGrp="1"/>
-          </p:cNvSpPr>
-          <p:nvPr>
-            <p:ph type="body" idx="3" sz="quarter"/>
-          </p:nvPr>
-        </p:nvSpPr>
-        <p:spPr/>
-        <p:txBody>
-          <a:bodyPr/>
-          <a:lstStyle/>
-          <a:p>
-            <a:r>
-              <a:t>所有结果都在同一 10,000 条 Query 和 2,337,178 个 POI 上做 float32 精确内积检索，不是 ANN 近似误差。早期一次直接向 Faiss GPU 连续扩容在 98% OOM，改用 CPU 暂存又在 90% 被系统以 137 终止；最终按两批加入 GPU 索引，并在构建前做 35.83 GiB 显存门禁，计算口径仍保持精确 FlatIP，失败运行没有留下不完整指标。</a:t>
-            </a:r>
-          </a:p>
-          <a:p/>
-          <a:p>
-            <a:r>
-              <a:t>E4 的 β=0.85 是离散候选中的 Validation 最优。完整去除类别中心 β=1.00 时 NDCG@10 轻微回落，说明类别公共方向既会造成同类拥挤，也包含少量有用语义，因此采用部分而非完全去除。</a:t>
-            </a:r>
-          </a:p>
-          <a:p/>
-          <a:p>
-            <a:r>
-              <a:t>增益不只出现在 Train 已见 Query：在 1,601 条未见相同 Query 文本的样本上，E2 将 Hit@10 从 55.59% 提高到 63.21%；在 2,309 条未见相同 Query–目标 POI 对的样本上，从 44.09% 提高到 52.14%。不过这些仍是连续向量召回结果，是否转化为生成式收益还要经过 SID 和 SFT。</a:t>
-            </a:r>
-          </a:p>
-        </p:txBody>
-      </p:sp>
-      <p:sp>
-        <p:nvSpPr>
-          <p:cNvPr id="4" name="Slide Number Placeholder 3"/>
-          <p:cNvSpPr>
-            <a:spLocks noGrp="1"/>
-          </p:cNvSpPr>
-          <p:nvPr>
-            <p:ph type="sldNum" idx="5" sz="quarter"/>
-          </p:nvPr>
-        </p:nvSpPr>
-        <p:spPr/>
-      </p:sp>
-    </p:spTree>
-  </p:cSld>
-  <p:clrMapOvr>
-    <a:masterClrMapping/>
-  </p:clrMapOvr>
-</p:notes>
-</file>
-
-<file path=ppt/notesSlides/notesSlide13.xml><?xml version="1.0" encoding="utf-8"?>
-<p:notes xmlns:a="http://schemas.openxmlformats.org/drawingml/2006/main" xmlns:p="http://schemas.openxmlformats.org/presentationml/2006/main" xmlns:r="http://schemas.openxmlformats.org/officeDocument/2006/relationships">
-  <p:cSld>
-    <p:spTree>
-      <p:nvGrpSpPr>
-        <p:cNvPr id="1" name=""/>
-        <p:cNvGrpSpPr/>
-        <p:nvPr/>
-      </p:nvGrpSpPr>
-      <p:grpSpPr>
-        <a:xfrm>
-          <a:off x="0" y="0"/>
-          <a:ext cx="0" cy="0"/>
-          <a:chOff x="0" y="0"/>
-          <a:chExt cx="0" cy="0"/>
-        </a:xfrm>
-      </p:grpSpPr>
-      <p:sp>
-        <p:nvSpPr>
-          <p:cNvPr id="2" name="Slide Image Placeholder 1"/>
-          <p:cNvSpPr>
-            <a:spLocks noGrp="1"/>
-          </p:cNvSpPr>
-          <p:nvPr>
-            <p:ph type="sldImg" idx="2"/>
-          </p:nvPr>
-        </p:nvSpPr>
-        <p:spPr/>
-      </p:sp>
-      <p:sp>
-        <p:nvSpPr>
-          <p:cNvPr id="3" name="Notes Placeholder 2"/>
-          <p:cNvSpPr>
-            <a:spLocks noGrp="1"/>
-          </p:cNvSpPr>
-          <p:nvPr>
-            <p:ph type="body" idx="3" sz="quarter"/>
-          </p:nvPr>
-        </p:nvSpPr>
-        <p:spPr/>
-        <p:txBody>
-          <a:bodyPr/>
-          <a:lstStyle/>
-          <a:p>
-            <a:r>
-              <a:t>RQ-KMeans 使用三层顺序残差聚类，不训练神经 Encoder/Decoder。正式协议固定 500,000 条同样本、每层 20 次迭代、3 次重启、seed 42、GPU float32；各布局没有加入类别监督、平衡损失或唯一化后缀，所以这里观察的是纯量化结构。</a:t>
-            </a:r>
-          </a:p>
-          <a:p/>
-          <a:p>
-            <a:r>
-              <a:t>对称 1024³ 中，RQ-KMeans 改善了总体唯一率和码本利用，但最大桶反而从 306 增加到 467，说明平均碰撞改善不代表最坏热点同步改善。容量前移后最大桶明显下降，说明更大的根码本对热点展开有效。</a:t>
-            </a:r>
-          </a:p>
-          <a:p/>
-          <a:p>
-            <a:r>
-              <a:t>三种布局的路径乘积都约为 2^30，但基础 Token 数是各层码本大小之和而不是乘积；因此 4096×1024×256 虽然结构最好，也会扩大词表和第一步分类空间。本页尚无这些 RQ-KMeans 布局的 SFT 结果，不能仅按唯一率选最终方案。</a:t>
-            </a:r>
-          </a:p>
-        </p:txBody>
-      </p:sp>
-      <p:sp>
-        <p:nvSpPr>
-          <p:cNvPr id="4" name="Slide Number Placeholder 3"/>
-          <p:cNvSpPr>
-            <a:spLocks noGrp="1"/>
-          </p:cNvSpPr>
-          <p:nvPr>
-            <p:ph type="sldNum" idx="5" sz="quarter"/>
-          </p:nvPr>
-        </p:nvSpPr>
-        <p:spPr/>
-      </p:sp>
-    </p:spTree>
-  </p:cSld>
-  <p:clrMapOvr>
-    <a:masterClrMapping/>
-  </p:clrMapOvr>
-</p:notes>
-</file>
-
-<file path=ppt/notesSlides/notesSlide14.xml><?xml version="1.0" encoding="utf-8"?>
-<p:notes xmlns:a="http://schemas.openxmlformats.org/drawingml/2006/main" xmlns:p="http://schemas.openxmlformats.org/presentationml/2006/main" xmlns:r="http://schemas.openxmlformats.org/officeDocument/2006/relationships">
-  <p:cSld>
-    <p:spTree>
-      <p:nvGrpSpPr>
-        <p:cNvPr id="1" name=""/>
-        <p:cNvGrpSpPr/>
-        <p:nvPr/>
-      </p:nvGrpSpPr>
-      <p:grpSpPr>
-        <a:xfrm>
-          <a:off x="0" y="0"/>
-          <a:ext cx="0" cy="0"/>
-          <a:chOff x="0" y="0"/>
-          <a:chExt cx="0" cy="0"/>
-        </a:xfrm>
-      </p:grpSpPr>
-      <p:sp>
-        <p:nvSpPr>
-          <p:cNvPr id="2" name="Slide Image Placeholder 1"/>
-          <p:cNvSpPr>
-            <a:spLocks noGrp="1"/>
-          </p:cNvSpPr>
-          <p:nvPr>
-            <p:ph type="sldImg" idx="2"/>
-          </p:nvPr>
-        </p:nvSpPr>
-        <p:spPr/>
-      </p:sp>
-      <p:sp>
-        <p:nvSpPr>
-          <p:cNvPr id="3" name="Notes Placeholder 2"/>
-          <p:cNvSpPr>
-            <a:spLocks noGrp="1"/>
-          </p:cNvSpPr>
-          <p:nvPr>
-            <p:ph type="body" idx="3" sz="quarter"/>
-          </p:nvPr>
-        </p:nvSpPr>
-        <p:spPr/>
-        <p:txBody>
-          <a:bodyPr/>
-          <a:lstStyle/>
-          <a:p>
-            <a:r>
-              <a:t>2×2 对照固定为同样的 1024³ 容量，目的是区分“Embedding 改了什么”和“Quantizer 改了什么”。E4 与 RQ-KMeans 都会重新展开拥挤区域，因此平均唯一率收益不相加；但 E4 把 RQ-KMeans 的最大桶从 467 降到 288，说明互补性主要体现在极端长尾，而不是平均指标。</a:t>
-            </a:r>
-          </a:p>
-          <a:p/>
-          <a:p>
-            <a:r>
-              <a:t>D1 micro-purity 使用的是 POI 静态 category_code，不是 Query 对第一层 Token 的可预测性。E4 主动削弱类别公共 Query 方向，因此浅层静态类别纯度下降是预期现象，不能直接判定生成变差；相反，也不能只用连续 Hit@K 断言 SID 更好，最终需要同一 SFT 协议验证。</a:t>
-            </a:r>
-          </a:p>
-          <a:p/>
-          <a:p>
-            <a:r>
-              <a:t>基于结构和工程成本，2048×1024×512 被保留为主候选，4096×1024×256 作为结构上界；二者都要与对称布局在下游可预测性上比较。</a:t>
-            </a:r>
-          </a:p>
-        </p:txBody>
-      </p:sp>
-      <p:sp>
-        <p:nvSpPr>
-          <p:cNvPr id="4" name="Slide Number Placeholder 3"/>
-          <p:cNvSpPr>
-            <a:spLocks noGrp="1"/>
-          </p:cNvSpPr>
-          <p:nvPr>
-            <p:ph type="sldNum" idx="5" sz="quarter"/>
-          </p:nvPr>
-        </p:nvSpPr>
-        <p:spPr/>
-      </p:sp>
-    </p:spTree>
-  </p:cSld>
-  <p:clrMapOvr>
-    <a:masterClrMapping/>
-  </p:clrMapOvr>
-</p:notes>
-</file>
-
-<file path=ppt/notesSlides/notesSlide15.xml><?xml version="1.0" encoding="utf-8"?>
-<p:notes xmlns:a="http://schemas.openxmlformats.org/drawingml/2006/main" xmlns:p="http://schemas.openxmlformats.org/presentationml/2006/main" xmlns:r="http://schemas.openxmlformats.org/officeDocument/2006/relationships">
-  <p:cSld>
-    <p:spTree>
-      <p:nvGrpSpPr>
-        <p:cNvPr id="1" name=""/>
-        <p:cNvGrpSpPr/>
-        <p:nvPr/>
-      </p:nvGrpSpPr>
-      <p:grpSpPr>
-        <a:xfrm>
-          <a:off x="0" y="0"/>
-          <a:ext cx="0" cy="0"/>
-          <a:chOff x="0" y="0"/>
-          <a:chExt cx="0" cy="0"/>
-        </a:xfrm>
-      </p:grpSpPr>
-      <p:sp>
-        <p:nvSpPr>
-          <p:cNvPr id="2" name="Slide Image Placeholder 1"/>
-          <p:cNvSpPr>
-            <a:spLocks noGrp="1"/>
-          </p:cNvSpPr>
-          <p:nvPr>
-            <p:ph type="sldImg" idx="2"/>
-          </p:nvPr>
-        </p:nvSpPr>
-        <p:spPr/>
-      </p:sp>
-      <p:sp>
-        <p:nvSpPr>
-          <p:cNvPr id="3" name="Notes Placeholder 2"/>
-          <p:cNvSpPr>
-            <a:spLocks noGrp="1"/>
-          </p:cNvSpPr>
-          <p:nvPr>
-            <p:ph type="body" idx="3" sz="quarter"/>
-          </p:nvPr>
-        </p:nvSpPr>
-        <p:spPr/>
-        <p:txBody>
-          <a:bodyPr/>
-          <a:lstStyle/>
-          <a:p>
-            <a:r>
-              <a:t>这里的熵不是按全目录 POI 均匀计数，而是按 7,586,410 条 Train 目标出现频次加权，更接近 SFT 实际看到的标签分布。“有效 S1 分支”定义为 2^H(S1)：它比码本名义大小更能反映模型第一步实际面对多少常见分支。</a:t>
-            </a:r>
-          </a:p>
-          <a:p/>
-          <a:p>
-            <a:r>
-              <a:t>容量前移时，完整路径熵只从约 15.25 增加到 15.44，但 H(S1) 和有效根分支显著增加，H(S2|S1)、H(S3|S1:S2)反而下降。也就是说，总任务信息量变化不大，只是难度被从有条件的后层搬到了无前缀的第一层。</a:t>
-            </a:r>
-          </a:p>
-          <a:p/>
-          <a:p>
-            <a:r>
-              <a:t>下一步应先补纯容量后移 512×1024×2048，和现有前移布局形成可归因对照。更有方法价值的候选是用全量可用的 402 个 category_code 作为原子根 Token，再用 1024×2048 量化类别残差；但必须保留 learned 512 根对照，否则无法区分“容量后移”和“类别监督”各自贡献。</a:t>
-            </a:r>
-          </a:p>
-        </p:txBody>
-      </p:sp>
-      <p:sp>
-        <p:nvSpPr>
-          <p:cNvPr id="4" name="Slide Number Placeholder 3"/>
-          <p:cNvSpPr>
-            <a:spLocks noGrp="1"/>
-          </p:cNvSpPr>
-          <p:nvPr>
-            <p:ph type="sldNum" idx="5" sz="quarter"/>
-          </p:nvPr>
-        </p:nvSpPr>
-        <p:spPr/>
-      </p:sp>
-    </p:spTree>
-  </p:cSld>
-  <p:clrMapOvr>
-    <a:masterClrMapping/>
-  </p:clrMapOvr>
-</p:notes>
-</file>
-
-<file path=ppt/notesSlides/notesSlide16.xml><?xml version="1.0" encoding="utf-8"?>
-<p:notes xmlns:a="http://schemas.openxmlformats.org/drawingml/2006/main" xmlns:p="http://schemas.openxmlformats.org/presentationml/2006/main" xmlns:r="http://schemas.openxmlformats.org/officeDocument/2006/relationships">
-  <p:cSld>
-    <p:spTree>
-      <p:nvGrpSpPr>
-        <p:cNvPr id="1" name=""/>
-        <p:cNvGrpSpPr/>
-        <p:nvPr/>
-      </p:nvGrpSpPr>
-      <p:grpSpPr>
-        <a:xfrm>
-          <a:off x="0" y="0"/>
-          <a:ext cx="0" cy="0"/>
-          <a:chOff x="0" y="0"/>
-          <a:chExt cx="0" cy="0"/>
-        </a:xfrm>
-      </p:grpSpPr>
-      <p:sp>
-        <p:nvSpPr>
-          <p:cNvPr id="2" name="Slide Image Placeholder 1"/>
-          <p:cNvSpPr>
-            <a:spLocks noGrp="1"/>
-          </p:cNvSpPr>
-          <p:nvPr>
-            <p:ph type="sldImg" idx="2"/>
-          </p:nvPr>
-        </p:nvSpPr>
-        <p:spPr/>
-      </p:sp>
-      <p:sp>
-        <p:nvSpPr>
-          <p:cNvPr id="3" name="Notes Placeholder 2"/>
-          <p:cNvSpPr>
-            <a:spLocks noGrp="1"/>
-          </p:cNvSpPr>
-          <p:nvPr>
-            <p:ph type="body" idx="3" sz="quarter"/>
-          </p:nvPr>
-        </p:nvSpPr>
-        <p:spPr/>
-        <p:txBody>
-          <a:bodyPr/>
-          <a:lstStyle/>
-          <a:p>
-            <a:r>
-              <a:t>后续最小实验矩阵建议保持三格：现有 E4 2048×1024×512、纯 learned 512×1024×2048、Category(402)×1024×2048。先比较唯一率、碰撞桶、目标频次熵和低支持分支；结构门禁通过后才按同一 Qwen、同一训练配置和固定 10,000 条运行 SFT，不直接为每个结构投入完整训练。</a:t>
-            </a:r>
-          </a:p>
-          <a:p/>
-          <a:p>
-            <a:r>
-              <a:t>类别根方案中，六位 category_code 应映射成单个特殊 Token，例如 &lt;CAT_281010&gt;，不能拆成数字串；后两层优先量化类别中心化后的 E4 残差，并共享全局码本，避免为长尾类别分别训练小码本。第一层类别纯度会因构造天然达到 100%，真正应看的是 Query→类别 Top-1/Top-5 和最终 HR/NDCG。</a:t>
-            </a:r>
-          </a:p>
-          <a:p/>
-          <a:p>
-            <a:r>
-              <a:t>当前结论还有三项边界：所有创新参数在 Validation 上选择，最终仍需独立 Test；GenPOI 与另外两种解码空间不同；随机关系后缀所需的楼号、父子和商铺关系覆盖率尚未完成全量审计。下一阶段应优先把可预测根、细粒度残差和最小关系后缀拆开验证。</a:t>
-            </a:r>
-          </a:p>
-        </p:txBody>
-      </p:sp>
-      <p:sp>
-        <p:nvSpPr>
-          <p:cNvPr id="4" name="Slide Number Placeholder 3"/>
-          <p:cNvSpPr>
-            <a:spLocks noGrp="1"/>
-          </p:cNvSpPr>
-          <p:nvPr>
-            <p:ph type="sldNum" idx="5" sz="quarter"/>
-          </p:nvPr>
-        </p:nvSpPr>
-        <p:spPr/>
-      </p:sp>
-    </p:spTree>
   </p:cSld>
   <p:clrMapOvr>
     <a:masterClrMapping/>
@@ -1198,21 +616,7 @@
           <a:bodyPr/>
           <a:lstStyle/>
           <a:p>
-            <a:r>
-              <a:t>表中的“SID 唯一率”都指追加 C/D 之前的基础三层 SID；三个方法在加入最终 Collision/Dedup 后都可以做到 POI 标识全局唯一。GenPOI 的 GID+SID 仍不是最终唯一 PID，最后一层条件 D 才把剩余碰撞完全展开。</a:t>
-            </a:r>
-          </a:p>
-          <a:p/>
-          <a:p>
-            <a:r>
-              <a:t>碰撞 Case 显示，很多大桶并非纯随机错误，而是连锁品牌网点、楼栋门牌、父子 POI、商场子店和出入口等语义相近实体。让它们共享基础 SID 有合理性，但随机序号只解决可逆映射，无法告诉模型“这是 4 号楼、东门还是某分店”。</a:t>
-            </a:r>
-          </a:p>
-          <a:p/>
-          <a:p>
-            <a:r>
-              <a:t>地图检索的错误代价高于一般推荐，因此后续需要把“共享检索语义”和“实体级身份”拆开：基础 SID 负责可预测语义，只有冲突项再用真实楼号、父实体、商铺号或局部空间关系完成最小消歧。</a:t>
-            </a:r>
+            <a:endParaRPr kumimoji="1" lang="zh-CN" altLang="en-US" dirty="0"/>
           </a:p>
         </p:txBody>
       </p:sp>
@@ -1245,580 +649,6 @@
         <p14:creationId xmlns:p14="http://schemas.microsoft.com/office/powerpoint/2010/main" val="79500724"/>
       </p:ext>
     </p:extLst>
-  </p:cSld>
-  <p:clrMapOvr>
-    <a:masterClrMapping/>
-  </p:clrMapOvr>
-</p:notes>
-</file>
-
-<file path=ppt/notesSlides/notesSlide3.xml><?xml version="1.0" encoding="utf-8"?>
-<p:notes xmlns:a="http://schemas.openxmlformats.org/drawingml/2006/main" xmlns:p="http://schemas.openxmlformats.org/presentationml/2006/main" xmlns:r="http://schemas.openxmlformats.org/officeDocument/2006/relationships">
-  <p:cSld>
-    <p:spTree>
-      <p:nvGrpSpPr>
-        <p:cNvPr id="1" name=""/>
-        <p:cNvGrpSpPr/>
-        <p:nvPr/>
-      </p:nvGrpSpPr>
-      <p:grpSpPr>
-        <a:xfrm>
-          <a:off x="0" y="0"/>
-          <a:ext cx="0" cy="0"/>
-          <a:chOff x="0" y="0"/>
-          <a:chExt cx="0" cy="0"/>
-        </a:xfrm>
-      </p:grpSpPr>
-      <p:sp>
-        <p:nvSpPr>
-          <p:cNvPr id="2" name="Slide Image Placeholder 1"/>
-          <p:cNvSpPr>
-            <a:spLocks noGrp="1"/>
-          </p:cNvSpPr>
-          <p:nvPr>
-            <p:ph type="sldImg" idx="2"/>
-          </p:nvPr>
-        </p:nvSpPr>
-        <p:spPr/>
-      </p:sp>
-      <p:sp>
-        <p:nvSpPr>
-          <p:cNvPr id="3" name="Notes Placeholder 2"/>
-          <p:cNvSpPr>
-            <a:spLocks noGrp="1"/>
-          </p:cNvSpPr>
-          <p:nvPr>
-            <p:ph type="body" idx="3" sz="quarter"/>
-          </p:nvPr>
-        </p:nvSpPr>
-        <p:spPr/>
-        <p:txBody>
-          <a:bodyPr/>
-          <a:lstStyle/>
-          <a:p>
-            <a:r>
-              <a:t>统一复现控制了北京 POI 目录、订单时间切分、Qwen3-0.6B、最近 10 条历史、三轮训练和固定评测集合；但保留了论文各自最关键的标识符和解码方式。因此这里比较的是三种方法在同一地图数据上的适配结果，不是直接复刻论文公开表格中的绝对数值。</a:t>
-            </a:r>
-          </a:p>
-          <a:p/>
-          <a:p>
-            <a:r>
-              <a:t>TIGER 的第四层 C 是固定长度规则：即使三层 SID 不碰撞，单例也追加 C0；碰撞桶内再使用 C1、C2……。GNPR 和 GenPOI 只对碰撞项追加 D，单例不增加该层，所以目标长度是条件变化的。</a:t>
-            </a:r>
-          </a:p>
-          <a:p/>
-          <a:p>
-            <a:r>
-              <a:t>GenPOI 的 SSP 只根据当前 Query 预测需要预填的地理前缀深度；TCG Trie 再限制每一步只能走向目录中的合法 PID。该约束不读取目标 POI，因此不存在目标泄漏，但它与 TIGER/GNPR 的无约束生成不是同一种搜索空间。</a:t>
-            </a:r>
-          </a:p>
-        </p:txBody>
-      </p:sp>
-      <p:sp>
-        <p:nvSpPr>
-          <p:cNvPr id="4" name="Slide Number Placeholder 3"/>
-          <p:cNvSpPr>
-            <a:spLocks noGrp="1"/>
-          </p:cNvSpPr>
-          <p:nvPr>
-            <p:ph type="sldNum" idx="5" sz="quarter"/>
-          </p:nvPr>
-        </p:nvSpPr>
-        <p:spPr/>
-      </p:sp>
-    </p:spTree>
-  </p:cSld>
-  <p:clrMapOvr>
-    <a:masterClrMapping/>
-  </p:clrMapOvr>
-</p:notes>
-</file>
-
-<file path=ppt/notesSlides/notesSlide4.xml><?xml version="1.0" encoding="utf-8"?>
-<p:notes xmlns:a="http://schemas.openxmlformats.org/drawingml/2006/main" xmlns:p="http://schemas.openxmlformats.org/presentationml/2006/main" xmlns:r="http://schemas.openxmlformats.org/officeDocument/2006/relationships">
-  <p:cSld>
-    <p:spTree>
-      <p:nvGrpSpPr>
-        <p:cNvPr id="1" name=""/>
-        <p:cNvGrpSpPr/>
-        <p:nvPr/>
-      </p:nvGrpSpPr>
-      <p:grpSpPr>
-        <a:xfrm>
-          <a:off x="0" y="0"/>
-          <a:ext cx="0" cy="0"/>
-          <a:chOff x="0" y="0"/>
-          <a:chExt cx="0" cy="0"/>
-        </a:xfrm>
-      </p:grpSpPr>
-      <p:sp>
-        <p:nvSpPr>
-          <p:cNvPr id="2" name="Slide Image Placeholder 1"/>
-          <p:cNvSpPr>
-            <a:spLocks noGrp="1"/>
-          </p:cNvSpPr>
-          <p:nvPr>
-            <p:ph type="sldImg" idx="2"/>
-          </p:nvPr>
-        </p:nvSpPr>
-        <p:spPr/>
-      </p:sp>
-      <p:sp>
-        <p:nvSpPr>
-          <p:cNvPr id="3" name="Notes Placeholder 2"/>
-          <p:cNvSpPr>
-            <a:spLocks noGrp="1"/>
-          </p:cNvSpPr>
-          <p:nvPr>
-            <p:ph type="body" idx="3" sz="quarter"/>
-          </p:nvPr>
-        </p:nvSpPr>
-        <p:spPr/>
-        <p:txBody>
-          <a:bodyPr/>
-          <a:lstStyle/>
-          <a:p>
-            <a:r>
-              <a:t>固定 10,000 条不是训练前 10,000 条，也不是曾用于 SFT smoke 的小样本，而是从 07-13 Validation 中按冻结业务键 order_id+searchid 对齐出的同一批样本。三种方法的样本顺序、目标 POI 和业务键均一致。</a:t>
-            </a:r>
-          </a:p>
-          <a:p/>
-          <a:p>
-            <a:r>
-              <a:t>历史事件必须早于目标订单，04-01—06-30 的历史窗口与 07 月目标期完全分离；空历史保留，避免只评估活跃用户。Test 只完成数据构建，没有用于参数选择或本次指标汇报。</a:t>
-            </a:r>
-          </a:p>
-          <a:p/>
-          <a:p>
-            <a:r>
-              <a:t>Validation 的订单键与 Train 不重叠，但地图查询文本自然会重复：10,000 条中有 8,399 条 Query 文本在 Train 出现，7,691 条精确 Query–目标 POI 对出现过。后续 Embedding 实验另外报告了未见 Query 和未见 Query–POI 子集，确认增益并非只来自文本复现。</a:t>
-            </a:r>
-          </a:p>
-        </p:txBody>
-      </p:sp>
-      <p:sp>
-        <p:nvSpPr>
-          <p:cNvPr id="4" name="Slide Number Placeholder 3"/>
-          <p:cNvSpPr>
-            <a:spLocks noGrp="1"/>
-          </p:cNvSpPr>
-          <p:nvPr>
-            <p:ph type="sldNum" idx="5" sz="quarter"/>
-          </p:nvPr>
-        </p:nvSpPr>
-        <p:spPr/>
-      </p:sp>
-    </p:spTree>
-  </p:cSld>
-  <p:clrMapOvr>
-    <a:masterClrMapping/>
-  </p:clrMapOvr>
-</p:notes>
-</file>
-
-<file path=ppt/notesSlides/notesSlide5.xml><?xml version="1.0" encoding="utf-8"?>
-<p:notes xmlns:a="http://schemas.openxmlformats.org/drawingml/2006/main" xmlns:p="http://schemas.openxmlformats.org/presentationml/2006/main" xmlns:r="http://schemas.openxmlformats.org/officeDocument/2006/relationships">
-  <p:cSld>
-    <p:spTree>
-      <p:nvGrpSpPr>
-        <p:cNvPr id="1" name=""/>
-        <p:cNvGrpSpPr/>
-        <p:nvPr/>
-      </p:nvGrpSpPr>
-      <p:grpSpPr>
-        <a:xfrm>
-          <a:off x="0" y="0"/>
-          <a:ext cx="0" cy="0"/>
-          <a:chOff x="0" y="0"/>
-          <a:chExt cx="0" cy="0"/>
-        </a:xfrm>
-      </p:grpSpPr>
-      <p:sp>
-        <p:nvSpPr>
-          <p:cNvPr id="2" name="Slide Image Placeholder 1"/>
-          <p:cNvSpPr>
-            <a:spLocks noGrp="1"/>
-          </p:cNvSpPr>
-          <p:nvPr>
-            <p:ph type="sldImg" idx="2"/>
-          </p:nvPr>
-        </p:nvSpPr>
-        <p:spPr/>
-      </p:sp>
-      <p:sp>
-        <p:nvSpPr>
-          <p:cNvPr id="3" name="Notes Placeholder 2"/>
-          <p:cNvSpPr>
-            <a:spLocks noGrp="1"/>
-          </p:cNvSpPr>
-          <p:nvPr>
-            <p:ph type="body" idx="3" sz="quarter"/>
-          </p:nvPr>
-        </p:nvSpPr>
-        <p:spPr/>
-        <p:txBody>
-          <a:bodyPr/>
-          <a:lstStyle/>
-          <a:p>
-            <a:r>
-              <a:t>TIGER 原本面向推荐，本项目把用户序列改为“当前 Query/GID + 最近历史 Query/GID/POI”，同时保留 RQ-VAE SID 和固定 Collision Code。GNPR 原始思路更偏行为表征；早期行为稀疏特征版本只覆盖 703,306 个有行为 POI，且用户哈希碰撞审计未通过，因此没有进入全目录复现，最终改用 BGE 文本、静态类别和 PlusCode6 的 content-geo 输入覆盖全部 POI。</a:t>
-            </a:r>
-          </a:p>
-          <a:p/>
-          <a:p>
-            <a:r>
-              <a:t>GenPOI 适配保留 GID、SSP 和 TCG；GeoPE32 版本额外做全局均值中心化，是为修复旧 GeoPE 输入第一层码本严重失活，不是为了修改评测协议。</a:t>
-            </a:r>
-          </a:p>
-          <a:p/>
-          <a:p>
-            <a:r>
-              <a:t>TIGER 使用 4×RTX PRO 6000D，另外两种使用 4×A100，但三组 SFT 的全局 batch 都是 512，均为 BF16 全参数训练、相同学习率和三轮保存。GPU 型号主要影响吞吐，不会合理解释 GNPR 的层级准确率差距；方法输入、SID 和解码差异才是主要变量。</a:t>
-            </a:r>
-          </a:p>
-        </p:txBody>
-      </p:sp>
-      <p:sp>
-        <p:nvSpPr>
-          <p:cNvPr id="4" name="Slide Number Placeholder 3"/>
-          <p:cNvSpPr>
-            <a:spLocks noGrp="1"/>
-          </p:cNvSpPr>
-          <p:nvPr>
-            <p:ph type="sldNum" idx="5" sz="quarter"/>
-          </p:nvPr>
-        </p:nvSpPr>
-        <p:spPr/>
-      </p:sp>
-    </p:spTree>
-  </p:cSld>
-  <p:clrMapOvr>
-    <a:masterClrMapping/>
-  </p:clrMapOvr>
-</p:notes>
-</file>
-
-<file path=ppt/notesSlides/notesSlide6.xml><?xml version="1.0" encoding="utf-8"?>
-<p:notes xmlns:a="http://schemas.openxmlformats.org/drawingml/2006/main" xmlns:p="http://schemas.openxmlformats.org/presentationml/2006/main" xmlns:r="http://schemas.openxmlformats.org/officeDocument/2006/relationships">
-  <p:cSld>
-    <p:spTree>
-      <p:nvGrpSpPr>
-        <p:cNvPr id="1" name=""/>
-        <p:cNvGrpSpPr/>
-        <p:nvPr/>
-      </p:nvGrpSpPr>
-      <p:grpSpPr>
-        <a:xfrm>
-          <a:off x="0" y="0"/>
-          <a:ext cx="0" cy="0"/>
-          <a:chOff x="0" y="0"/>
-          <a:chExt cx="0" cy="0"/>
-        </a:xfrm>
-      </p:grpSpPr>
-      <p:sp>
-        <p:nvSpPr>
-          <p:cNvPr id="2" name="Slide Image Placeholder 1"/>
-          <p:cNvSpPr>
-            <a:spLocks noGrp="1"/>
-          </p:cNvSpPr>
-          <p:nvPr>
-            <p:ph type="sldImg" idx="2"/>
-          </p:nvPr>
-        </p:nvSpPr>
-        <p:spPr/>
-      </p:sp>
-      <p:sp>
-        <p:nvSpPr>
-          <p:cNvPr id="3" name="Notes Placeholder 2"/>
-          <p:cNvSpPr>
-            <a:spLocks noGrp="1"/>
-          </p:cNvSpPr>
-          <p:nvPr>
-            <p:ph type="body" idx="3" sz="quarter"/>
-          </p:nvPr>
-        </p:nvSpPr>
-        <p:spPr/>
-        <p:txBody>
-          <a:bodyPr/>
-          <a:lstStyle/>
-          <a:p>
-            <a:r>
-              <a:t>SID 训练中出现过一次明确失败：最初直接沿用 learning rate=1e-3 的 256×3 RQ-VAE，最终只得到 330 个不同 SID，Validation 三层仅使用 55/3/2 个码字，最大桶达到 29,472，属于码本塌缩。通过小规模稳定性扫描将学习率改为 3e-4 后，三种容量均正常训练，失败产物未纳入表中结果。</a:t>
-            </a:r>
-          </a:p>
-          <a:p/>
-          <a:p>
-            <a:r>
-              <a:t>TIGER 的全量 Tokenized Cache 第一次在 Train 分词完成后被系统回收；已生成的 16 个 Arrow 分片没有重算，而是用 4 个 worker 逐分片校验并恢复 Validation，最终正式 Cache 退出码为 0，首/中/末样本与 Assistant label 均通过回读。</a:t>
-            </a:r>
-          </a:p>
-          <a:p/>
-          <a:p>
-            <a:r>
-              <a:t>无约束评测中的非法 ID 不是 JSON 解析失败，而是模型生成了语法看似正确、但不存在于冻结全量映射中的四元组。评测没有删除或补位，而是保留原 Beam 排名并计为 miss，避免人为抬高召回。</a:t>
-            </a:r>
-          </a:p>
-        </p:txBody>
-      </p:sp>
-      <p:sp>
-        <p:nvSpPr>
-          <p:cNvPr id="4" name="Slide Number Placeholder 3"/>
-          <p:cNvSpPr>
-            <a:spLocks noGrp="1"/>
-          </p:cNvSpPr>
-          <p:nvPr>
-            <p:ph type="sldNum" idx="5" sz="quarter"/>
-          </p:nvPr>
-        </p:nvSpPr>
-        <p:spPr/>
-      </p:sp>
-    </p:spTree>
-  </p:cSld>
-  <p:clrMapOvr>
-    <a:masterClrMapping/>
-  </p:clrMapOvr>
-</p:notes>
-</file>
-
-<file path=ppt/notesSlides/notesSlide7.xml><?xml version="1.0" encoding="utf-8"?>
-<p:notes xmlns:a="http://schemas.openxmlformats.org/drawingml/2006/main" xmlns:p="http://schemas.openxmlformats.org/presentationml/2006/main" xmlns:r="http://schemas.openxmlformats.org/officeDocument/2006/relationships">
-  <p:cSld>
-    <p:spTree>
-      <p:nvGrpSpPr>
-        <p:cNvPr id="1" name=""/>
-        <p:cNvGrpSpPr/>
-        <p:nvPr/>
-      </p:nvGrpSpPr>
-      <p:grpSpPr>
-        <a:xfrm>
-          <a:off x="0" y="0"/>
-          <a:ext cx="0" cy="0"/>
-          <a:chOff x="0" y="0"/>
-          <a:chExt cx="0" cy="0"/>
-        </a:xfrm>
-      </p:grpSpPr>
-      <p:sp>
-        <p:nvSpPr>
-          <p:cNvPr id="2" name="Slide Image Placeholder 1"/>
-          <p:cNvSpPr>
-            <a:spLocks noGrp="1"/>
-          </p:cNvSpPr>
-          <p:nvPr>
-            <p:ph type="sldImg" idx="2"/>
-          </p:nvPr>
-        </p:nvSpPr>
-        <p:spPr/>
-      </p:sp>
-      <p:sp>
-        <p:nvSpPr>
-          <p:cNvPr id="3" name="Notes Placeholder 2"/>
-          <p:cNvSpPr>
-            <a:spLocks noGrp="1"/>
-          </p:cNvSpPr>
-          <p:nvPr>
-            <p:ph type="body" idx="3" sz="quarter"/>
-          </p:nvPr>
-        </p:nvSpPr>
-        <p:spPr/>
-        <p:txBody>
-          <a:bodyPr/>
-          <a:lstStyle/>
-          <a:p>
-            <a:r>
-              <a:t>GNPR 的容量选择并非简单取最大码本。1024×3 的原 epoch 20 checkpoint 出现严重塌缩：全量仅 73,183 个不同 SID，最大桶 4,757；随后从头复跑 epoch 16，虽然浅层类别纯度较高，但唯一率只有 63.18%，第三层利用率 45.31%，且跨 GPU 复现不稳定，因此最终冻结更均衡的 512×3，而不是使用 1024。</a:t>
-            </a:r>
-          </a:p>
-          <a:p/>
-          <a:p>
-            <a:r>
-              <a:t>SFT 训练本身完整结束：四卡 A100 完成 3 epoch 和 16,167 step，最终模型、三个 checkpoint、Tokenizer、Trainer state 和指标均已落盘。训练平台显示 failed 的直接原因是 Trainer 退出后继续执行旧包装脚本，第 87 行存在未闭合双引号，shell 以 exit code 2 结束；错误发生在模型保存和 NCCL 正常销毁之后。三个 checkpoint 经 CUDA 实际生成核验可用，无需重训，当前入口也已通过 bash -n。</a:t>
-            </a:r>
-          </a:p>
-          <a:p/>
-          <a:p>
-            <a:r>
-              <a:t>逐层诊断表明真正差异集中在第一层，而不是训练资源：GNPR 后两层在 gold prefix 条件下并不差，但 S1 与 Query/历史的对应关系弱，第一步错误会在自由生成中阻断正确路径。</a:t>
-            </a:r>
-          </a:p>
-        </p:txBody>
-      </p:sp>
-      <p:sp>
-        <p:nvSpPr>
-          <p:cNvPr id="4" name="Slide Number Placeholder 3"/>
-          <p:cNvSpPr>
-            <a:spLocks noGrp="1"/>
-          </p:cNvSpPr>
-          <p:nvPr>
-            <p:ph type="sldNum" idx="5" sz="quarter"/>
-          </p:nvPr>
-        </p:nvSpPr>
-        <p:spPr/>
-      </p:sp>
-    </p:spTree>
-  </p:cSld>
-  <p:clrMapOvr>
-    <a:masterClrMapping/>
-  </p:clrMapOvr>
-</p:notes>
-</file>
-
-<file path=ppt/notesSlides/notesSlide8.xml><?xml version="1.0" encoding="utf-8"?>
-<p:notes xmlns:a="http://schemas.openxmlformats.org/drawingml/2006/main" xmlns:p="http://schemas.openxmlformats.org/presentationml/2006/main" xmlns:r="http://schemas.openxmlformats.org/officeDocument/2006/relationships">
-  <p:cSld>
-    <p:spTree>
-      <p:nvGrpSpPr>
-        <p:cNvPr id="1" name=""/>
-        <p:cNvGrpSpPr/>
-        <p:nvPr/>
-      </p:nvGrpSpPr>
-      <p:grpSpPr>
-        <a:xfrm>
-          <a:off x="0" y="0"/>
-          <a:ext cx="0" cy="0"/>
-          <a:chOff x="0" y="0"/>
-          <a:chExt cx="0" cy="0"/>
-        </a:xfrm>
-      </p:grpSpPr>
-      <p:sp>
-        <p:nvSpPr>
-          <p:cNvPr id="2" name="Slide Image Placeholder 1"/>
-          <p:cNvSpPr>
-            <a:spLocks noGrp="1"/>
-          </p:cNvSpPr>
-          <p:nvPr>
-            <p:ph type="sldImg" idx="2"/>
-          </p:nvPr>
-        </p:nvSpPr>
-        <p:spPr/>
-      </p:sp>
-      <p:sp>
-        <p:nvSpPr>
-          <p:cNvPr id="3" name="Notes Placeholder 2"/>
-          <p:cNvSpPr>
-            <a:spLocks noGrp="1"/>
-          </p:cNvSpPr>
-          <p:nvPr>
-            <p:ph type="body" idx="3" sz="quarter"/>
-          </p:nvPr>
-        </p:nvSpPr>
-        <p:spPr/>
-        <p:txBody>
-          <a:bodyPr/>
-          <a:lstStyle/>
-          <a:p>
-            <a:r>
-              <a:t>旧 GeoPE32 输入的第一层只使用 59/1024 个码字。原因是 BGE-M3 的全局公共方向经过逐 POI 地理旋转后干扰粗层聚类；对全量向量做均值中心化和 L2 归一化，并复用 TIGER 稳定 RQ-VAE 骨架后，三种容量的三层码本都达到 100% 使用。需要注意，Centered 版本改善的是码本健康和下游可学习性，三层 SID 唯一率并没有超过旧版，因此不能写成所有结构指标全面提高。</a:t>
-            </a:r>
-          </a:p>
-          <a:p/>
-          <a:p>
-            <a:r>
-              <a:t>Geohash6 先消解了约 37.95% 的原碰撞 POI，剩余 690,673 条再使用条件 D。TCG Trie 包含 2,337,178 个叶子和约 642 万节点，保证每条生成路径都能落到目录 POI；100% Valid PID 是约束机制的保证，不代表模型独立学会了所有合法组合。</a:t>
-            </a:r>
-          </a:p>
-          <a:p/>
-          <a:p>
-            <a:r>
-              <a:t>本次四卡 A100 Trainer 同样已完成并保存三个完整 checkpoint，平台外层随后显示 failed，但日志没有 Trainer traceback，模型文件、优化器、调度器、随机状态和 Tokenizer 均完整，当前入口语法检查通过，因此无需重训。Centered 三轮正式评测本身退出码为 0，未发生 OOM 或恢复事件。</a:t>
-            </a:r>
-          </a:p>
-        </p:txBody>
-      </p:sp>
-      <p:sp>
-        <p:nvSpPr>
-          <p:cNvPr id="4" name="Slide Number Placeholder 3"/>
-          <p:cNvSpPr>
-            <a:spLocks noGrp="1"/>
-          </p:cNvSpPr>
-          <p:nvPr>
-            <p:ph type="sldNum" idx="5" sz="quarter"/>
-          </p:nvPr>
-        </p:nvSpPr>
-        <p:spPr/>
-      </p:sp>
-    </p:spTree>
-  </p:cSld>
-  <p:clrMapOvr>
-    <a:masterClrMapping/>
-  </p:clrMapOvr>
-</p:notes>
-</file>
-
-<file path=ppt/notesSlides/notesSlide9.xml><?xml version="1.0" encoding="utf-8"?>
-<p:notes xmlns:a="http://schemas.openxmlformats.org/drawingml/2006/main" xmlns:p="http://schemas.openxmlformats.org/presentationml/2006/main" xmlns:r="http://schemas.openxmlformats.org/officeDocument/2006/relationships">
-  <p:cSld>
-    <p:spTree>
-      <p:nvGrpSpPr>
-        <p:cNvPr id="1" name=""/>
-        <p:cNvGrpSpPr/>
-        <p:nvPr/>
-      </p:nvGrpSpPr>
-      <p:grpSpPr>
-        <a:xfrm>
-          <a:off x="0" y="0"/>
-          <a:ext cx="0" cy="0"/>
-          <a:chOff x="0" y="0"/>
-          <a:chExt cx="0" cy="0"/>
-        </a:xfrm>
-      </p:grpSpPr>
-      <p:sp>
-        <p:nvSpPr>
-          <p:cNvPr id="2" name="Slide Image Placeholder 1"/>
-          <p:cNvSpPr>
-            <a:spLocks noGrp="1"/>
-          </p:cNvSpPr>
-          <p:nvPr>
-            <p:ph type="sldImg" idx="2"/>
-          </p:nvPr>
-        </p:nvSpPr>
-        <p:spPr/>
-      </p:sp>
-      <p:sp>
-        <p:nvSpPr>
-          <p:cNvPr id="3" name="Notes Placeholder 2"/>
-          <p:cNvSpPr>
-            <a:spLocks noGrp="1"/>
-          </p:cNvSpPr>
-          <p:nvPr>
-            <p:ph type="body" idx="3" sz="quarter"/>
-          </p:nvPr>
-        </p:nvSpPr>
-        <p:spPr/>
-        <p:txBody>
-          <a:bodyPr/>
-          <a:lstStyle/>
-          <a:p>
-            <a:r>
-              <a:t>三种方法共用同一 10,000 条业务样本和 Beam=10，但不能把表中的端到端差值全部归因于 SID：GenPOI 使用 SSP+Trie，另外两种是无约束生成。Valid ID 更适合作为解码诊断项，不是相关性指标；Trie 可以把合法率提升到 100%，但不会自动保证目标 POI 排在前面。</a:t>
-            </a:r>
-          </a:p>
-          <a:p/>
-          <a:p>
-            <a:r>
-              <a:t>TIGER/GNPR 对非法候选不做过滤后补位，所以其 HR@K 是在原始十个 Beam 位置上计算的。若删除非法项后再补充合法候选，指标会虚高，也会破坏和当前结果的可复现性。</a:t>
-            </a:r>
-          </a:p>
-          <a:p/>
-          <a:p>
-            <a:r>
-              <a:t>目前只在这一批 Validation 上选择 epoch 3，尚未做完整 Validation、独立 Test 或统计显著性检验。GenPOI 相对 TIGER 的优势很小，当前更稳妥的表述是“完整方法略优”，而不是已经证明地理前缀或某个量化器单独有效。</a:t>
-            </a:r>
-          </a:p>
-        </p:txBody>
-      </p:sp>
-      <p:sp>
-        <p:nvSpPr>
-          <p:cNvPr id="4" name="Slide Number Placeholder 3"/>
-          <p:cNvSpPr>
-            <a:spLocks noGrp="1"/>
-          </p:cNvSpPr>
-          <p:nvPr>
-            <p:ph type="sldNum" idx="5" sz="quarter"/>
-          </p:nvPr>
-        </p:nvSpPr>
-        <p:spPr/>
-      </p:sp>
-    </p:spTree>
   </p:cSld>
   <p:clrMapOvr>
     <a:masterClrMapping/>

</xml_diff>